<commit_message>
manual postprocess soft materials run
</commit_message>
<xml_diff>
--- a/docs/presentation/Early Warning Scan intership presentation - Daan Kuijpers.pptx
+++ b/docs/presentation/Early Warning Scan intership presentation - Daan Kuijpers.pptx
@@ -5,7 +5,7 @@
     <p:sldMasterId id="2147483660" r:id="rId1"/>
   </p:sldMasterIdLst>
   <p:notesMasterIdLst>
-    <p:notesMasterId r:id="rId22"/>
+    <p:notesMasterId r:id="rId23"/>
   </p:notesMasterIdLst>
   <p:sldIdLst>
     <p:sldId id="267" r:id="rId2"/>
@@ -22,12 +22,13 @@
     <p:sldId id="302" r:id="rId13"/>
     <p:sldId id="303" r:id="rId14"/>
     <p:sldId id="304" r:id="rId15"/>
-    <p:sldId id="305" r:id="rId16"/>
-    <p:sldId id="306" r:id="rId17"/>
-    <p:sldId id="307" r:id="rId18"/>
-    <p:sldId id="308" r:id="rId19"/>
+    <p:sldId id="312" r:id="rId16"/>
+    <p:sldId id="305" r:id="rId17"/>
+    <p:sldId id="306" r:id="rId18"/>
+    <p:sldId id="307" r:id="rId19"/>
     <p:sldId id="311" r:id="rId20"/>
-    <p:sldId id="310" r:id="rId21"/>
+    <p:sldId id="308" r:id="rId21"/>
+    <p:sldId id="310" r:id="rId22"/>
   </p:sldIdLst>
   <p:sldSz cx="9144000" cy="5143500" type="screen16x9"/>
   <p:notesSz cx="6858000" cy="9144000"/>
@@ -288,7 +289,7 @@
           <a:p>
             <a:fld id="{05F25DE2-B715-4EA4-8CF0-DA425EA806A7}" type="datetimeFigureOut">
               <a:rPr lang="en-GB" smtClean="0"/>
-              <a:t>04/06/2026</a:t>
+              <a:t>05/06/2026</a:t>
             </a:fld>
             <a:endParaRPr lang="en-GB"/>
           </a:p>
@@ -729,7 +730,7 @@
           <a:p>
             <a:fld id="{AA799BBE-B871-48D7-983C-C0B1D7156DCD}" type="slidenum">
               <a:rPr lang="en-GB" smtClean="0"/>
-              <a:t>20</a:t>
+              <a:t>21</a:t>
             </a:fld>
             <a:endParaRPr lang="en-GB" dirty="0"/>
           </a:p>
@@ -6748,7 +6749,15 @@
           <a:p>
             <a:r>
               <a:rPr lang="en-US" dirty="0"/>
-              <a:t>DDD</a:t>
+              <a:t>The selected xoffset055 </a:t>
+            </a:r>
+            <a:r>
+              <a:rPr lang="en-US" dirty="0" err="1"/>
+              <a:t>chestwall</a:t>
+            </a:r>
+            <a:r>
+              <a:rPr lang="en-US" dirty="0"/>
+              <a:t> creates the first fair anatomical baseline.</a:t>
             </a:r>
             <a:br>
               <a:rPr lang="en-US" dirty="0"/>
@@ -6758,9 +6767,46 @@
           <a:p>
             <a:pPr lvl="2"/>
             <a:r>
-              <a:rPr lang="en-GB" dirty="0"/>
-              <a:t>DDD</a:t>
-            </a:r>
+              <a:rPr lang="en-US" dirty="0"/>
+              <a:t>Transverse </a:t>
+            </a:r>
+            <a:r>
+              <a:rPr lang="en-US" dirty="0" err="1"/>
+              <a:t>chestwall</a:t>
+            </a:r>
+            <a:r>
+              <a:rPr lang="en-US" dirty="0"/>
+              <a:t> curvature with volume preservation.</a:t>
+            </a:r>
+          </a:p>
+          <a:p>
+            <a:pPr lvl="2"/>
+            <a:r>
+              <a:rPr lang="en-US" dirty="0"/>
+              <a:t>Nipple and glandular positions are auto-aligned.</a:t>
+            </a:r>
+          </a:p>
+          <a:p>
+            <a:pPr lvl="2"/>
+            <a:r>
+              <a:rPr lang="en-US" dirty="0" err="1"/>
+              <a:t>Chestwall</a:t>
+            </a:r>
+            <a:r>
+              <a:rPr lang="en-US" dirty="0"/>
+              <a:t> curvature is treated as patient-dependent sensitivity.</a:t>
+            </a:r>
+          </a:p>
+          <a:p>
+            <a:pPr lvl="2"/>
+            <a:r>
+              <a:rPr lang="en-US" dirty="0"/>
+              <a:t>This stage becomes the anatomical base for later variants.</a:t>
+            </a:r>
+          </a:p>
+          <a:p>
+            <a:pPr lvl="2"/>
+            <a:endParaRPr lang="en-GB" dirty="0"/>
           </a:p>
         </p:txBody>
       </p:sp>
@@ -7167,7 +7213,15 @@
           <a:p>
             <a:r>
               <a:rPr lang="en-US" dirty="0"/>
-              <a:t>DDD</a:t>
+              <a:t>The glandular region is represented as a </a:t>
+            </a:r>
+            <a:r>
+              <a:rPr lang="en-US" dirty="0" err="1"/>
+              <a:t>chestwall</a:t>
+            </a:r>
+            <a:r>
+              <a:rPr lang="en-US" dirty="0"/>
+              <a:t>-aware lobule spread.</a:t>
             </a:r>
             <a:br>
               <a:rPr lang="en-US" dirty="0"/>
@@ -7177,9 +7231,34 @@
           <a:p>
             <a:pPr lvl="2"/>
             <a:r>
-              <a:rPr lang="en-GB" dirty="0"/>
-              <a:t>DDD</a:t>
-            </a:r>
+              <a:rPr lang="en-US" dirty="0"/>
+              <a:t>Reference glandular fraction is approximately 24.3%.</a:t>
+            </a:r>
+          </a:p>
+          <a:p>
+            <a:pPr lvl="2"/>
+            <a:r>
+              <a:rPr lang="en-US" dirty="0"/>
+              <a:t>More anatomically meaningful than a simple fraction sweep.</a:t>
+            </a:r>
+          </a:p>
+          <a:p>
+            <a:pPr lvl="2"/>
+            <a:r>
+              <a:rPr lang="en-US" dirty="0"/>
+              <a:t>Compact/reference/wide variants can test spatial distribution.</a:t>
+            </a:r>
+          </a:p>
+          <a:p>
+            <a:pPr lvl="2"/>
+            <a:r>
+              <a:rPr lang="en-US" dirty="0"/>
+              <a:t>The reference case continues into Stage 4 and Stage 5 controls.</a:t>
+            </a:r>
+          </a:p>
+          <a:p>
+            <a:pPr lvl="2"/>
+            <a:endParaRPr lang="en-GB" dirty="0"/>
           </a:p>
         </p:txBody>
       </p:sp>
@@ -7586,7 +7665,7 @@
           <a:p>
             <a:r>
               <a:rPr lang="en-US" dirty="0"/>
-              <a:t>DDD</a:t>
+              <a:t>Stage 4 provides a framework for profile and landmark sensitivity.</a:t>
             </a:r>
             <a:br>
               <a:rPr lang="en-US" dirty="0"/>
@@ -7597,8 +7676,33 @@
             <a:pPr lvl="2"/>
             <a:r>
               <a:rPr lang="en-GB" dirty="0"/>
-              <a:t>DDD</a:t>
-            </a:r>
+              <a:t>Reference case remains a no-asymmetry control.</a:t>
+            </a:r>
+          </a:p>
+          <a:p>
+            <a:pPr lvl="2"/>
+            <a:r>
+              <a:rPr lang="en-GB" dirty="0"/>
+              <a:t>Profile asymmetry and nipple-shift variants are geometry-tested.</a:t>
+            </a:r>
+          </a:p>
+          <a:p>
+            <a:pPr lvl="2"/>
+            <a:r>
+              <a:rPr lang="en-GB" dirty="0"/>
+              <a:t>Current quantitative results are diagnostic rather than final.</a:t>
+            </a:r>
+          </a:p>
+          <a:p>
+            <a:pPr lvl="2"/>
+            <a:r>
+              <a:rPr lang="en-GB" dirty="0"/>
+              <a:t>Useful for later patient-specific shape variation.</a:t>
+            </a:r>
+          </a:p>
+          <a:p>
+            <a:pPr lvl="2"/>
+            <a:endParaRPr lang="en-GB" dirty="0"/>
           </a:p>
         </p:txBody>
       </p:sp>
@@ -8005,7 +8109,7 @@
           <a:p>
             <a:r>
               <a:rPr lang="en-US" dirty="0"/>
-              <a:t>DDD</a:t>
+              <a:t>Support and skin dominate the realism of the dynamic response.</a:t>
             </a:r>
             <a:br>
               <a:rPr lang="en-US" dirty="0"/>
@@ -8015,9 +8119,34 @@
           <a:p>
             <a:pPr lvl="2"/>
             <a:r>
-              <a:rPr lang="en-GB" dirty="0"/>
-              <a:t>DDD</a:t>
-            </a:r>
+              <a:rPr lang="en-US" dirty="0"/>
+              <a:t>No-Cooper case is the current stable control.</a:t>
+            </a:r>
+          </a:p>
+          <a:p>
+            <a:pPr lvl="2"/>
+            <a:r>
+              <a:rPr lang="en-US" dirty="0"/>
+              <a:t>Cooper-ligament scaffolds are implemented but not yet robust enough for final solves.</a:t>
+            </a:r>
+          </a:p>
+          <a:p>
+            <a:pPr lvl="2"/>
+            <a:r>
+              <a:rPr lang="en-US" dirty="0"/>
+              <a:t>Shell/scaffold skin caused unrealistic surface buckling.</a:t>
+            </a:r>
+          </a:p>
+          <a:p>
+            <a:pPr lvl="2"/>
+            <a:r>
+              <a:rPr lang="en-US" dirty="0"/>
+              <a:t>Volumetric skin is the preferred route for further calibration.</a:t>
+            </a:r>
+          </a:p>
+          <a:p>
+            <a:pPr lvl="2"/>
+            <a:endParaRPr lang="en-GB" dirty="0"/>
           </a:p>
         </p:txBody>
       </p:sp>
@@ -8424,7 +8553,7 @@
           <a:p>
             <a:r>
               <a:rPr lang="en-US" dirty="0"/>
-              <a:t>DDD</a:t>
+              <a:t>The volumetric skin improves anatomy but strongly damps displacement amplitude.</a:t>
             </a:r>
             <a:br>
               <a:rPr lang="en-US" dirty="0"/>
@@ -8435,8 +8564,41 @@
             <a:pPr lvl="2"/>
             <a:r>
               <a:rPr lang="en-GB" dirty="0"/>
-              <a:t>DDD</a:t>
-            </a:r>
+              <a:t>No-skin 1.25g: higher peak displacement.</a:t>
+            </a:r>
+          </a:p>
+          <a:p>
+            <a:pPr lvl="2"/>
+            <a:r>
+              <a:rPr lang="en-GB" dirty="0"/>
+              <a:t>Volumetric skin 1.25g: lower displacement but visually stable motion.</a:t>
+            </a:r>
+          </a:p>
+          <a:p>
+            <a:pPr lvl="2"/>
+            <a:r>
+              <a:rPr lang="en-GB" dirty="0"/>
+              <a:t>Stress hotspots occur mainly near </a:t>
+            </a:r>
+            <a:r>
+              <a:rPr lang="en-GB" dirty="0" err="1"/>
+              <a:t>chestwall</a:t>
+            </a:r>
+            <a:r>
+              <a:rPr lang="en-GB" dirty="0"/>
+              <a:t>/support interfaces.</a:t>
+            </a:r>
+          </a:p>
+          <a:p>
+            <a:pPr lvl="2"/>
+            <a:r>
+              <a:rPr lang="en-GB" dirty="0"/>
+              <a:t>Soft-interior volumetric skin is the next calibration scout.</a:t>
+            </a:r>
+          </a:p>
+          <a:p>
+            <a:pPr lvl="2"/>
+            <a:endParaRPr lang="en-GB" dirty="0"/>
           </a:p>
         </p:txBody>
       </p:sp>
@@ -8473,7 +8635,7 @@
         <p:cNvPr id="1" name="">
           <a:extLst>
             <a:ext uri="{FF2B5EF4-FFF2-40B4-BE49-F238E27FC236}">
-              <a16:creationId xmlns:a16="http://schemas.microsoft.com/office/drawing/2014/main" id="{A8F4E788-FD07-8A6A-FAD7-0C9C299FB16A}"/>
+              <a16:creationId xmlns:a16="http://schemas.microsoft.com/office/drawing/2014/main" id="{3B1351C3-6C91-BC3C-13DC-0C0B3F243C9C}"/>
             </a:ext>
           </a:extLst>
         </p:cNvPr>
@@ -8493,7 +8655,7 @@
           <p:cNvPr id="2" name="Title 1">
             <a:extLst>
               <a:ext uri="{FF2B5EF4-FFF2-40B4-BE49-F238E27FC236}">
-                <a16:creationId xmlns:a16="http://schemas.microsoft.com/office/drawing/2014/main" id="{282A267A-D4D5-9335-5C6F-9058C35FF8E1}"/>
+                <a16:creationId xmlns:a16="http://schemas.microsoft.com/office/drawing/2014/main" id="{72D0CB94-8087-246D-C4CE-D931D52C9B6F}"/>
               </a:ext>
             </a:extLst>
           </p:cNvPr>
@@ -8511,7 +8673,7 @@
           <a:p>
             <a:r>
               <a:rPr lang="en-US" dirty="0"/>
-              <a:t>Stage 6: Tumor Implementation</a:t>
+              <a:t>Stage 5: Motion Comparison</a:t>
             </a:r>
             <a:endParaRPr lang="en-NL" dirty="0"/>
           </a:p>
@@ -8522,7 +8684,7 @@
           <p:cNvPr id="4" name="Footer Placeholder 3">
             <a:extLst>
               <a:ext uri="{FF2B5EF4-FFF2-40B4-BE49-F238E27FC236}">
-                <a16:creationId xmlns:a16="http://schemas.microsoft.com/office/drawing/2014/main" id="{3AB825F4-23B6-0590-DF9E-D9A90439D85E}"/>
+                <a16:creationId xmlns:a16="http://schemas.microsoft.com/office/drawing/2014/main" id="{632D9449-9907-39CC-7AEC-D7CE52A78193}"/>
               </a:ext>
             </a:extLst>
           </p:cNvPr>
@@ -8551,7 +8713,7 @@
           <p:cNvPr id="5" name="Slide Number Placeholder 4">
             <a:extLst>
               <a:ext uri="{FF2B5EF4-FFF2-40B4-BE49-F238E27FC236}">
-                <a16:creationId xmlns:a16="http://schemas.microsoft.com/office/drawing/2014/main" id="{51FBD15E-2A98-5D78-8266-64E0BF70A09F}"/>
+                <a16:creationId xmlns:a16="http://schemas.microsoft.com/office/drawing/2014/main" id="{8345DF18-34D0-6311-6DBD-9E0322700B5F}"/>
               </a:ext>
             </a:extLst>
           </p:cNvPr>
@@ -8580,7 +8742,7 @@
           <p:cNvPr id="9" name="Picture 8">
             <a:extLst>
               <a:ext uri="{FF2B5EF4-FFF2-40B4-BE49-F238E27FC236}">
-                <a16:creationId xmlns:a16="http://schemas.microsoft.com/office/drawing/2014/main" id="{2B21EE98-A4D4-06AD-E497-F28F8C6F2DC2}"/>
+                <a16:creationId xmlns:a16="http://schemas.microsoft.com/office/drawing/2014/main" id="{19F4EFBA-E6AA-3C87-C871-9B6ADB687086}"/>
               </a:ext>
             </a:extLst>
           </p:cNvPr>
@@ -8616,7 +8778,7 @@
           <p:cNvPr id="7" name="Content Placeholder 6">
             <a:extLst>
               <a:ext uri="{FF2B5EF4-FFF2-40B4-BE49-F238E27FC236}">
-                <a16:creationId xmlns:a16="http://schemas.microsoft.com/office/drawing/2014/main" id="{5D94903A-A235-2741-8931-09F9F9C3FE70}"/>
+                <a16:creationId xmlns:a16="http://schemas.microsoft.com/office/drawing/2014/main" id="{7FA0969C-EB22-C88A-47C3-5E161E5EFD88}"/>
               </a:ext>
             </a:extLst>
           </p:cNvPr>
@@ -8654,7 +8816,7 @@
           <p:cNvPr id="3" name="Tijdelijke aanduiding voor inhoud 2">
             <a:extLst>
               <a:ext uri="{FF2B5EF4-FFF2-40B4-BE49-F238E27FC236}">
-                <a16:creationId xmlns:a16="http://schemas.microsoft.com/office/drawing/2014/main" id="{5DAB9F88-6464-B4B2-6F3C-39093DDE69E0}"/>
+                <a16:creationId xmlns:a16="http://schemas.microsoft.com/office/drawing/2014/main" id="{99FA826F-97F7-D656-2BA4-E2F42FB8CE90}"/>
               </a:ext>
             </a:extLst>
           </p:cNvPr>
@@ -8843,7 +9005,7 @@
           <a:p>
             <a:r>
               <a:rPr lang="en-US" dirty="0"/>
-              <a:t>DDD</a:t>
+              <a:t>The motion pattern is comparable, but the skin layer changes the amplitude.</a:t>
             </a:r>
             <a:br>
               <a:rPr lang="en-US" dirty="0"/>
@@ -8853,16 +9015,41 @@
           <a:p>
             <a:pPr lvl="2"/>
             <a:r>
-              <a:rPr lang="en-GB" dirty="0"/>
-              <a:t>DDD</a:t>
-            </a:r>
+              <a:rPr lang="en-US" dirty="0"/>
+              <a:t>Manual Derived Values were used as a reliable fallback for solve-only scouts.</a:t>
+            </a:r>
+          </a:p>
+          <a:p>
+            <a:pPr lvl="2"/>
+            <a:r>
+              <a:rPr lang="en-US" dirty="0"/>
+              <a:t>Peak-time and time-series metrics are sufficient for amplitude screening.</a:t>
+            </a:r>
+          </a:p>
+          <a:p>
+            <a:pPr lvl="2"/>
+            <a:r>
+              <a:rPr lang="en-US" dirty="0"/>
+              <a:t>Animations are useful for visual QA but should not replace quantitative metrics.</a:t>
+            </a:r>
+          </a:p>
+          <a:p>
+            <a:pPr lvl="2"/>
+            <a:r>
+              <a:rPr lang="en-US" dirty="0"/>
+              <a:t>Automated postprocessing is still being debugged for heavy result files.</a:t>
+            </a:r>
+          </a:p>
+          <a:p>
+            <a:pPr lvl="2"/>
+            <a:endParaRPr lang="en-GB" dirty="0"/>
           </a:p>
         </p:txBody>
       </p:sp>
     </p:spTree>
     <p:extLst>
       <p:ext uri="{BB962C8B-B14F-4D97-AF65-F5344CB8AC3E}">
-        <p14:creationId xmlns:p14="http://schemas.microsoft.com/office/powerpoint/2010/main" val="3288508072"/>
+        <p14:creationId xmlns:p14="http://schemas.microsoft.com/office/powerpoint/2010/main" val="3954485758"/>
       </p:ext>
     </p:extLst>
   </p:cSld>
@@ -8892,7 +9079,7 @@
         <p:cNvPr id="1" name="">
           <a:extLst>
             <a:ext uri="{FF2B5EF4-FFF2-40B4-BE49-F238E27FC236}">
-              <a16:creationId xmlns:a16="http://schemas.microsoft.com/office/drawing/2014/main" id="{815465C0-79E4-B316-6E99-BCC55678207A}"/>
+              <a16:creationId xmlns:a16="http://schemas.microsoft.com/office/drawing/2014/main" id="{A8F4E788-FD07-8A6A-FAD7-0C9C299FB16A}"/>
             </a:ext>
           </a:extLst>
         </p:cNvPr>
@@ -8912,7 +9099,7 @@
           <p:cNvPr id="2" name="Title 1">
             <a:extLst>
               <a:ext uri="{FF2B5EF4-FFF2-40B4-BE49-F238E27FC236}">
-                <a16:creationId xmlns:a16="http://schemas.microsoft.com/office/drawing/2014/main" id="{3434695B-BDCF-DB1B-E82D-9BF2CAAE2EB6}"/>
+                <a16:creationId xmlns:a16="http://schemas.microsoft.com/office/drawing/2014/main" id="{282A267A-D4D5-9335-5C6F-9058C35FF8E1}"/>
               </a:ext>
             </a:extLst>
           </p:cNvPr>
@@ -8930,7 +9117,7 @@
           <a:p>
             <a:r>
               <a:rPr lang="en-US" dirty="0"/>
-              <a:t>Full model Comparison</a:t>
+              <a:t>Stage 6: Tumor Implementation</a:t>
             </a:r>
             <a:endParaRPr lang="en-NL" dirty="0"/>
           </a:p>
@@ -8941,7 +9128,7 @@
           <p:cNvPr id="4" name="Footer Placeholder 3">
             <a:extLst>
               <a:ext uri="{FF2B5EF4-FFF2-40B4-BE49-F238E27FC236}">
-                <a16:creationId xmlns:a16="http://schemas.microsoft.com/office/drawing/2014/main" id="{7E58B1F5-8F7B-8D32-96DD-E43070ABA72F}"/>
+                <a16:creationId xmlns:a16="http://schemas.microsoft.com/office/drawing/2014/main" id="{3AB825F4-23B6-0590-DF9E-D9A90439D85E}"/>
               </a:ext>
             </a:extLst>
           </p:cNvPr>
@@ -8970,7 +9157,7 @@
           <p:cNvPr id="5" name="Slide Number Placeholder 4">
             <a:extLst>
               <a:ext uri="{FF2B5EF4-FFF2-40B4-BE49-F238E27FC236}">
-                <a16:creationId xmlns:a16="http://schemas.microsoft.com/office/drawing/2014/main" id="{AC92B9CE-AD7F-B9D4-B925-5ACA4CB53899}"/>
+                <a16:creationId xmlns:a16="http://schemas.microsoft.com/office/drawing/2014/main" id="{51FBD15E-2A98-5D78-8266-64E0BF70A09F}"/>
               </a:ext>
             </a:extLst>
           </p:cNvPr>
@@ -8999,7 +9186,7 @@
           <p:cNvPr id="9" name="Picture 8">
             <a:extLst>
               <a:ext uri="{FF2B5EF4-FFF2-40B4-BE49-F238E27FC236}">
-                <a16:creationId xmlns:a16="http://schemas.microsoft.com/office/drawing/2014/main" id="{FDA8681B-20C3-E0DF-2ECE-C8853BB2A0BC}"/>
+                <a16:creationId xmlns:a16="http://schemas.microsoft.com/office/drawing/2014/main" id="{2B21EE98-A4D4-06AD-E497-F28F8C6F2DC2}"/>
               </a:ext>
             </a:extLst>
           </p:cNvPr>
@@ -9035,7 +9222,7 @@
           <p:cNvPr id="7" name="Content Placeholder 6">
             <a:extLst>
               <a:ext uri="{FF2B5EF4-FFF2-40B4-BE49-F238E27FC236}">
-                <a16:creationId xmlns:a16="http://schemas.microsoft.com/office/drawing/2014/main" id="{C2818636-43CE-40F5-CF67-5A7570753ED8}"/>
+                <a16:creationId xmlns:a16="http://schemas.microsoft.com/office/drawing/2014/main" id="{5D94903A-A235-2741-8931-09F9F9C3FE70}"/>
               </a:ext>
             </a:extLst>
           </p:cNvPr>
@@ -9073,7 +9260,7 @@
           <p:cNvPr id="3" name="Tijdelijke aanduiding voor inhoud 2">
             <a:extLst>
               <a:ext uri="{FF2B5EF4-FFF2-40B4-BE49-F238E27FC236}">
-                <a16:creationId xmlns:a16="http://schemas.microsoft.com/office/drawing/2014/main" id="{71EACE2D-697F-C97E-51DA-FCB9C3A85674}"/>
+                <a16:creationId xmlns:a16="http://schemas.microsoft.com/office/drawing/2014/main" id="{5DAB9F88-6464-B4B2-6F3C-39093DDE69E0}"/>
               </a:ext>
             </a:extLst>
           </p:cNvPr>
@@ -9262,7 +9449,7 @@
           <a:p>
             <a:r>
               <a:rPr lang="en-US" dirty="0"/>
-              <a:t>DDD</a:t>
+              <a:t>Stage 6 introduces tumors as controlled stiffness-mask sensitivities.</a:t>
             </a:r>
             <a:br>
               <a:rPr lang="en-US" dirty="0"/>
@@ -9272,16 +9459,41 @@
           <a:p>
             <a:pPr lvl="2"/>
             <a:r>
-              <a:rPr lang="en-GB" dirty="0"/>
-              <a:t>DDD</a:t>
-            </a:r>
+              <a:rPr lang="en-US" dirty="0"/>
+              <a:t>Analytic spherical tumor mask inside the breast volume.</a:t>
+            </a:r>
+          </a:p>
+          <a:p>
+            <a:pPr lvl="2"/>
+            <a:r>
+              <a:rPr lang="en-US" dirty="0"/>
+              <a:t>Not a separate clinical segmentation yet.</a:t>
+            </a:r>
+          </a:p>
+          <a:p>
+            <a:pPr lvl="2"/>
+            <a:r>
+              <a:rPr lang="en-US" dirty="0"/>
+              <a:t>Variants test size, position and stiffness.</a:t>
+            </a:r>
+          </a:p>
+          <a:p>
+            <a:pPr lvl="2"/>
+            <a:r>
+              <a:rPr lang="en-US" dirty="0"/>
+              <a:t>Upper-outer and surface-proximal locations are prioritized for future solves.</a:t>
+            </a:r>
+          </a:p>
+          <a:p>
+            <a:pPr lvl="2"/>
+            <a:endParaRPr lang="en-GB" dirty="0"/>
           </a:p>
         </p:txBody>
       </p:sp>
     </p:spTree>
     <p:extLst>
       <p:ext uri="{BB962C8B-B14F-4D97-AF65-F5344CB8AC3E}">
-        <p14:creationId xmlns:p14="http://schemas.microsoft.com/office/powerpoint/2010/main" val="4162204579"/>
+        <p14:creationId xmlns:p14="http://schemas.microsoft.com/office/powerpoint/2010/main" val="3288508072"/>
       </p:ext>
     </p:extLst>
   </p:cSld>
@@ -9311,7 +9523,7 @@
         <p:cNvPr id="1" name="">
           <a:extLst>
             <a:ext uri="{FF2B5EF4-FFF2-40B4-BE49-F238E27FC236}">
-              <a16:creationId xmlns:a16="http://schemas.microsoft.com/office/drawing/2014/main" id="{4241ABF7-508E-C70A-AA43-252E3FCDF21A}"/>
+              <a16:creationId xmlns:a16="http://schemas.microsoft.com/office/drawing/2014/main" id="{815465C0-79E4-B316-6E99-BCC55678207A}"/>
             </a:ext>
           </a:extLst>
         </p:cNvPr>
@@ -9331,7 +9543,7 @@
           <p:cNvPr id="2" name="Title 1">
             <a:extLst>
               <a:ext uri="{FF2B5EF4-FFF2-40B4-BE49-F238E27FC236}">
-                <a16:creationId xmlns:a16="http://schemas.microsoft.com/office/drawing/2014/main" id="{D0C7C50D-7B0A-BFFA-01FC-B5A087382AB2}"/>
+                <a16:creationId xmlns:a16="http://schemas.microsoft.com/office/drawing/2014/main" id="{3434695B-BDCF-DB1B-E82D-9BF2CAAE2EB6}"/>
               </a:ext>
             </a:extLst>
           </p:cNvPr>
@@ -9349,7 +9561,7 @@
           <a:p>
             <a:r>
               <a:rPr lang="en-US" dirty="0"/>
-              <a:t>Current Limitations</a:t>
+              <a:t>Full model Comparison</a:t>
             </a:r>
             <a:endParaRPr lang="en-NL" dirty="0"/>
           </a:p>
@@ -9360,7 +9572,7 @@
           <p:cNvPr id="4" name="Footer Placeholder 3">
             <a:extLst>
               <a:ext uri="{FF2B5EF4-FFF2-40B4-BE49-F238E27FC236}">
-                <a16:creationId xmlns:a16="http://schemas.microsoft.com/office/drawing/2014/main" id="{49DF3432-5946-E73F-CFA9-C404234CAE01}"/>
+                <a16:creationId xmlns:a16="http://schemas.microsoft.com/office/drawing/2014/main" id="{7E58B1F5-8F7B-8D32-96DD-E43070ABA72F}"/>
               </a:ext>
             </a:extLst>
           </p:cNvPr>
@@ -9389,7 +9601,7 @@
           <p:cNvPr id="5" name="Slide Number Placeholder 4">
             <a:extLst>
               <a:ext uri="{FF2B5EF4-FFF2-40B4-BE49-F238E27FC236}">
-                <a16:creationId xmlns:a16="http://schemas.microsoft.com/office/drawing/2014/main" id="{C51C194D-6302-0FA7-45DC-FFC7737054CD}"/>
+                <a16:creationId xmlns:a16="http://schemas.microsoft.com/office/drawing/2014/main" id="{AC92B9CE-AD7F-B9D4-B925-5ACA4CB53899}"/>
               </a:ext>
             </a:extLst>
           </p:cNvPr>
@@ -9418,7 +9630,7 @@
           <p:cNvPr id="9" name="Picture 8">
             <a:extLst>
               <a:ext uri="{FF2B5EF4-FFF2-40B4-BE49-F238E27FC236}">
-                <a16:creationId xmlns:a16="http://schemas.microsoft.com/office/drawing/2014/main" id="{9FD614DD-C5DB-B32F-DA3D-938BF234974B}"/>
+                <a16:creationId xmlns:a16="http://schemas.microsoft.com/office/drawing/2014/main" id="{FDA8681B-20C3-E0DF-2ECE-C8853BB2A0BC}"/>
               </a:ext>
             </a:extLst>
           </p:cNvPr>
@@ -9454,7 +9666,7 @@
           <p:cNvPr id="7" name="Content Placeholder 6">
             <a:extLst>
               <a:ext uri="{FF2B5EF4-FFF2-40B4-BE49-F238E27FC236}">
-                <a16:creationId xmlns:a16="http://schemas.microsoft.com/office/drawing/2014/main" id="{61113FAE-5291-6E5D-BC8B-CD2A51777899}"/>
+                <a16:creationId xmlns:a16="http://schemas.microsoft.com/office/drawing/2014/main" id="{C2818636-43CE-40F5-CF67-5A7570753ED8}"/>
               </a:ext>
             </a:extLst>
           </p:cNvPr>
@@ -9492,7 +9704,7 @@
           <p:cNvPr id="3" name="Tijdelijke aanduiding voor inhoud 2">
             <a:extLst>
               <a:ext uri="{FF2B5EF4-FFF2-40B4-BE49-F238E27FC236}">
-                <a16:creationId xmlns:a16="http://schemas.microsoft.com/office/drawing/2014/main" id="{16CC90C1-4A7F-0FD3-7321-19C42DEECB0E}"/>
+                <a16:creationId xmlns:a16="http://schemas.microsoft.com/office/drawing/2014/main" id="{71EACE2D-697F-C97E-51DA-FCB9C3A85674}"/>
               </a:ext>
             </a:extLst>
           </p:cNvPr>
@@ -9681,7 +9893,7 @@
           <a:p>
             <a:r>
               <a:rPr lang="en-US" dirty="0"/>
-              <a:t>DDD</a:t>
+              <a:t>The next quantitative result should be a matched no-tumor versus tumor comparison on the chosen baseline.</a:t>
             </a:r>
             <a:br>
               <a:rPr lang="en-US" dirty="0"/>
@@ -9691,16 +9903,41 @@
           <a:p>
             <a:pPr lvl="2"/>
             <a:r>
-              <a:rPr lang="en-GB" dirty="0"/>
-              <a:t>DDD</a:t>
-            </a:r>
+              <a:rPr lang="en-US" dirty="0"/>
+              <a:t>First choose the final Stage 5 baseline: volumetric skin with calibrated interior stiffness.</a:t>
+            </a:r>
+          </a:p>
+          <a:p>
+            <a:pPr lvl="2"/>
+            <a:r>
+              <a:rPr lang="en-US" dirty="0"/>
+              <a:t>Then run matched control and tumor cases with identical geometry and excitation.</a:t>
+            </a:r>
+          </a:p>
+          <a:p>
+            <a:pPr lvl="2"/>
+            <a:r>
+              <a:rPr lang="en-US" dirty="0"/>
+              <a:t>Evaluate surface displacement, nipple/landmark displacement and stress around the lesion.</a:t>
+            </a:r>
+          </a:p>
+          <a:p>
+            <a:pPr lvl="2"/>
+            <a:r>
+              <a:rPr lang="en-US" dirty="0"/>
+              <a:t>Avoid running many tumor cases before the baseline amplitude is credible.</a:t>
+            </a:r>
+          </a:p>
+          <a:p>
+            <a:pPr lvl="2"/>
+            <a:endParaRPr lang="en-GB" dirty="0"/>
           </a:p>
         </p:txBody>
       </p:sp>
     </p:spTree>
     <p:extLst>
       <p:ext uri="{BB962C8B-B14F-4D97-AF65-F5344CB8AC3E}">
-        <p14:creationId xmlns:p14="http://schemas.microsoft.com/office/powerpoint/2010/main" val="1791822740"/>
+        <p14:creationId xmlns:p14="http://schemas.microsoft.com/office/powerpoint/2010/main" val="4162204579"/>
       </p:ext>
     </p:extLst>
   </p:cSld>
@@ -9730,7 +9967,7 @@
         <p:cNvPr id="1" name="">
           <a:extLst>
             <a:ext uri="{FF2B5EF4-FFF2-40B4-BE49-F238E27FC236}">
-              <a16:creationId xmlns:a16="http://schemas.microsoft.com/office/drawing/2014/main" id="{AC4E87FA-CD57-1DAF-17B6-58E3F23CCBAA}"/>
+              <a16:creationId xmlns:a16="http://schemas.microsoft.com/office/drawing/2014/main" id="{4241ABF7-508E-C70A-AA43-252E3FCDF21A}"/>
             </a:ext>
           </a:extLst>
         </p:cNvPr>
@@ -9750,7 +9987,7 @@
           <p:cNvPr id="2" name="Title 1">
             <a:extLst>
               <a:ext uri="{FF2B5EF4-FFF2-40B4-BE49-F238E27FC236}">
-                <a16:creationId xmlns:a16="http://schemas.microsoft.com/office/drawing/2014/main" id="{0CA6FA44-E9D2-FC53-9F81-80BFC0EA08F1}"/>
+                <a16:creationId xmlns:a16="http://schemas.microsoft.com/office/drawing/2014/main" id="{D0C7C50D-7B0A-BFFA-01FC-B5A087382AB2}"/>
               </a:ext>
             </a:extLst>
           </p:cNvPr>
@@ -9768,7 +10005,7 @@
           <a:p>
             <a:r>
               <a:rPr lang="en-US" dirty="0"/>
-              <a:t>Next Steps</a:t>
+              <a:t>Current Limitations</a:t>
             </a:r>
             <a:endParaRPr lang="en-NL" dirty="0"/>
           </a:p>
@@ -9779,7 +10016,7 @@
           <p:cNvPr id="4" name="Footer Placeholder 3">
             <a:extLst>
               <a:ext uri="{FF2B5EF4-FFF2-40B4-BE49-F238E27FC236}">
-                <a16:creationId xmlns:a16="http://schemas.microsoft.com/office/drawing/2014/main" id="{F7B42189-4491-3F10-6382-1C95CA11DA51}"/>
+                <a16:creationId xmlns:a16="http://schemas.microsoft.com/office/drawing/2014/main" id="{49DF3432-5946-E73F-CFA9-C404234CAE01}"/>
               </a:ext>
             </a:extLst>
           </p:cNvPr>
@@ -9808,7 +10045,7 @@
           <p:cNvPr id="5" name="Slide Number Placeholder 4">
             <a:extLst>
               <a:ext uri="{FF2B5EF4-FFF2-40B4-BE49-F238E27FC236}">
-                <a16:creationId xmlns:a16="http://schemas.microsoft.com/office/drawing/2014/main" id="{86DA0BF9-4609-ECC7-C377-FA1ED5937967}"/>
+                <a16:creationId xmlns:a16="http://schemas.microsoft.com/office/drawing/2014/main" id="{C51C194D-6302-0FA7-45DC-FFC7737054CD}"/>
               </a:ext>
             </a:extLst>
           </p:cNvPr>
@@ -9837,7 +10074,7 @@
           <p:cNvPr id="9" name="Picture 8">
             <a:extLst>
               <a:ext uri="{FF2B5EF4-FFF2-40B4-BE49-F238E27FC236}">
-                <a16:creationId xmlns:a16="http://schemas.microsoft.com/office/drawing/2014/main" id="{04B7BE0B-59F3-EFA7-CF0D-3D1245A5964A}"/>
+                <a16:creationId xmlns:a16="http://schemas.microsoft.com/office/drawing/2014/main" id="{9FD614DD-C5DB-B32F-DA3D-938BF234974B}"/>
               </a:ext>
             </a:extLst>
           </p:cNvPr>
@@ -9873,7 +10110,7 @@
           <p:cNvPr id="7" name="Content Placeholder 6">
             <a:extLst>
               <a:ext uri="{FF2B5EF4-FFF2-40B4-BE49-F238E27FC236}">
-                <a16:creationId xmlns:a16="http://schemas.microsoft.com/office/drawing/2014/main" id="{74A4DC81-497E-D19A-3425-96F23C2B7974}"/>
+                <a16:creationId xmlns:a16="http://schemas.microsoft.com/office/drawing/2014/main" id="{61113FAE-5291-6E5D-BC8B-CD2A51777899}"/>
               </a:ext>
             </a:extLst>
           </p:cNvPr>
@@ -9911,7 +10148,7 @@
           <p:cNvPr id="3" name="Tijdelijke aanduiding voor inhoud 2">
             <a:extLst>
               <a:ext uri="{FF2B5EF4-FFF2-40B4-BE49-F238E27FC236}">
-                <a16:creationId xmlns:a16="http://schemas.microsoft.com/office/drawing/2014/main" id="{B427C76F-C358-0FB5-953F-04290E619B06}"/>
+                <a16:creationId xmlns:a16="http://schemas.microsoft.com/office/drawing/2014/main" id="{16CC90C1-4A7F-0FD3-7321-19C42DEECB0E}"/>
               </a:ext>
             </a:extLst>
           </p:cNvPr>
@@ -10100,7 +10337,7 @@
           <a:p>
             <a:r>
               <a:rPr lang="en-US" dirty="0"/>
-              <a:t>DDD</a:t>
+              <a:t>The model is a controlled research pipeline, not a clinical patient-specific model yet.</a:t>
             </a:r>
             <a:br>
               <a:rPr lang="en-US" dirty="0"/>
@@ -10110,16 +10347,48 @@
           <a:p>
             <a:pPr lvl="2"/>
             <a:r>
-              <a:rPr lang="en-GB" dirty="0"/>
-              <a:t>DDD</a:t>
-            </a:r>
+              <a:rPr lang="en-US" dirty="0"/>
+              <a:t>Geometry is parametric rather than patient-specific.</a:t>
+            </a:r>
+          </a:p>
+          <a:p>
+            <a:pPr lvl="2"/>
+            <a:r>
+              <a:rPr lang="en-US" dirty="0"/>
+              <a:t>Dynamic input is an excitation model, not a validated real jump reproduction.</a:t>
+            </a:r>
+          </a:p>
+          <a:p>
+            <a:pPr lvl="2"/>
+            <a:r>
+              <a:rPr lang="en-US" dirty="0"/>
+              <a:t>Material stiffness and damping still need calibration.</a:t>
+            </a:r>
+          </a:p>
+          <a:p>
+            <a:pPr lvl="2"/>
+            <a:r>
+              <a:rPr lang="en-US" dirty="0"/>
+              <a:t>Cooper support and tumor effects require robust matched solves.</a:t>
+            </a:r>
+          </a:p>
+          <a:p>
+            <a:pPr lvl="2"/>
+            <a:r>
+              <a:rPr lang="en-US" dirty="0"/>
+              <a:t>Automated postprocess is still under improvement for large MPH files.</a:t>
+            </a:r>
+          </a:p>
+          <a:p>
+            <a:pPr lvl="2"/>
+            <a:endParaRPr lang="en-GB" dirty="0"/>
           </a:p>
         </p:txBody>
       </p:sp>
     </p:spTree>
     <p:extLst>
       <p:ext uri="{BB962C8B-B14F-4D97-AF65-F5344CB8AC3E}">
-        <p14:creationId xmlns:p14="http://schemas.microsoft.com/office/powerpoint/2010/main" val="159822574"/>
+        <p14:creationId xmlns:p14="http://schemas.microsoft.com/office/powerpoint/2010/main" val="1791822740"/>
       </p:ext>
     </p:extLst>
   </p:cSld>
@@ -10519,7 +10788,7 @@
           <a:p>
             <a:r>
               <a:rPr lang="en-US" dirty="0"/>
-              <a:t>DDD</a:t>
+              <a:t>The project establishes a reproducible COMSOL route for controlled EWS model development.</a:t>
             </a:r>
             <a:br>
               <a:rPr lang="en-US" dirty="0"/>
@@ -10529,9 +10798,34 @@
           <a:p>
             <a:pPr lvl="2"/>
             <a:r>
-              <a:rPr lang="en-GB" dirty="0"/>
-              <a:t>DDD</a:t>
-            </a:r>
+              <a:rPr lang="en-US" dirty="0"/>
+              <a:t>A staged anatomical baseline is available.</a:t>
+            </a:r>
+          </a:p>
+          <a:p>
+            <a:pPr lvl="2"/>
+            <a:r>
+              <a:rPr lang="en-US" dirty="0"/>
+              <a:t>Dynamic excitation, skin and material choices are now the key calibration issues.</a:t>
+            </a:r>
+          </a:p>
+          <a:p>
+            <a:pPr lvl="2"/>
+            <a:r>
+              <a:rPr lang="en-US" dirty="0"/>
+              <a:t>Tumor placement is geometry-ready for matched sensitivity runs.</a:t>
+            </a:r>
+          </a:p>
+          <a:p>
+            <a:pPr lvl="2"/>
+            <a:r>
+              <a:rPr lang="en-US" dirty="0"/>
+              <a:t>The pipeline can support future patient-specific geometry and EWS-data coupling.</a:t>
+            </a:r>
+          </a:p>
+          <a:p>
+            <a:pPr lvl="2"/>
+            <a:endParaRPr lang="en-GB" dirty="0"/>
           </a:p>
         </p:txBody>
       </p:sp>
@@ -11003,6 +11297,481 @@
 <file path=ppt/slides/slide20.xml><?xml version="1.0" encoding="utf-8"?>
 <p:sld xmlns:a="http://schemas.openxmlformats.org/drawingml/2006/main" xmlns:r="http://schemas.openxmlformats.org/officeDocument/2006/relationships" xmlns:p="http://schemas.openxmlformats.org/presentationml/2006/main">
   <p:cSld>
+    <p:spTree>
+      <p:nvGrpSpPr>
+        <p:cNvPr id="1" name="">
+          <a:extLst>
+            <a:ext uri="{FF2B5EF4-FFF2-40B4-BE49-F238E27FC236}">
+              <a16:creationId xmlns:a16="http://schemas.microsoft.com/office/drawing/2014/main" id="{AC4E87FA-CD57-1DAF-17B6-58E3F23CCBAA}"/>
+            </a:ext>
+          </a:extLst>
+        </p:cNvPr>
+        <p:cNvGrpSpPr/>
+        <p:nvPr/>
+      </p:nvGrpSpPr>
+      <p:grpSpPr>
+        <a:xfrm>
+          <a:off x="0" y="0"/>
+          <a:ext cx="0" cy="0"/>
+          <a:chOff x="0" y="0"/>
+          <a:chExt cx="0" cy="0"/>
+        </a:xfrm>
+      </p:grpSpPr>
+      <p:sp>
+        <p:nvSpPr>
+          <p:cNvPr id="2" name="Title 1">
+            <a:extLst>
+              <a:ext uri="{FF2B5EF4-FFF2-40B4-BE49-F238E27FC236}">
+                <a16:creationId xmlns:a16="http://schemas.microsoft.com/office/drawing/2014/main" id="{0CA6FA44-E9D2-FC53-9F81-80BFC0EA08F1}"/>
+              </a:ext>
+            </a:extLst>
+          </p:cNvPr>
+          <p:cNvSpPr>
+            <a:spLocks noGrp="1"/>
+          </p:cNvSpPr>
+          <p:nvPr>
+            <p:ph type="title"/>
+          </p:nvPr>
+        </p:nvSpPr>
+        <p:spPr/>
+        <p:txBody>
+          <a:bodyPr/>
+          <a:lstStyle/>
+          <a:p>
+            <a:r>
+              <a:rPr lang="en-US" dirty="0"/>
+              <a:t>Next Steps</a:t>
+            </a:r>
+            <a:endParaRPr lang="en-NL" dirty="0"/>
+          </a:p>
+        </p:txBody>
+      </p:sp>
+      <p:sp>
+        <p:nvSpPr>
+          <p:cNvPr id="4" name="Footer Placeholder 3">
+            <a:extLst>
+              <a:ext uri="{FF2B5EF4-FFF2-40B4-BE49-F238E27FC236}">
+                <a16:creationId xmlns:a16="http://schemas.microsoft.com/office/drawing/2014/main" id="{F7B42189-4491-3F10-6382-1C95CA11DA51}"/>
+              </a:ext>
+            </a:extLst>
+          </p:cNvPr>
+          <p:cNvSpPr>
+            <a:spLocks noGrp="1"/>
+          </p:cNvSpPr>
+          <p:nvPr>
+            <p:ph type="ftr" sz="quarter" idx="11"/>
+          </p:nvPr>
+        </p:nvSpPr>
+        <p:spPr/>
+        <p:txBody>
+          <a:bodyPr/>
+          <a:lstStyle/>
+          <a:p>
+            <a:r>
+              <a:rPr lang="en-US"/>
+              <a:t>COMSOL FEM Breast Model for Early Warning Scan</a:t>
+            </a:r>
+            <a:endParaRPr lang="en-GB" dirty="0"/>
+          </a:p>
+        </p:txBody>
+      </p:sp>
+      <p:sp>
+        <p:nvSpPr>
+          <p:cNvPr id="5" name="Slide Number Placeholder 4">
+            <a:extLst>
+              <a:ext uri="{FF2B5EF4-FFF2-40B4-BE49-F238E27FC236}">
+                <a16:creationId xmlns:a16="http://schemas.microsoft.com/office/drawing/2014/main" id="{86DA0BF9-4609-ECC7-C377-FA1ED5937967}"/>
+              </a:ext>
+            </a:extLst>
+          </p:cNvPr>
+          <p:cNvSpPr>
+            <a:spLocks noGrp="1"/>
+          </p:cNvSpPr>
+          <p:nvPr>
+            <p:ph type="sldNum" sz="quarter" idx="12"/>
+          </p:nvPr>
+        </p:nvSpPr>
+        <p:spPr/>
+        <p:txBody>
+          <a:bodyPr/>
+          <a:lstStyle/>
+          <a:p>
+            <a:fld id="{C194BDB0-F4EA-4DD6-8281-CCE2440D0CE0}" type="slidenum">
+              <a:rPr lang="en-GB" smtClean="0"/>
+              <a:t>20</a:t>
+            </a:fld>
+            <a:endParaRPr lang="en-GB" dirty="0"/>
+          </a:p>
+        </p:txBody>
+      </p:sp>
+      <p:pic>
+        <p:nvPicPr>
+          <p:cNvPr id="9" name="Picture 8">
+            <a:extLst>
+              <a:ext uri="{FF2B5EF4-FFF2-40B4-BE49-F238E27FC236}">
+                <a16:creationId xmlns:a16="http://schemas.microsoft.com/office/drawing/2014/main" id="{04B7BE0B-59F3-EFA7-CF0D-3D1245A5964A}"/>
+              </a:ext>
+            </a:extLst>
+          </p:cNvPr>
+          <p:cNvPicPr>
+            <a:picLocks noChangeAspect="1"/>
+          </p:cNvPicPr>
+          <p:nvPr/>
+        </p:nvPicPr>
+        <p:blipFill>
+          <a:blip r:embed="rId2">
+            <a:extLst>
+              <a:ext uri="{28A0092B-C50C-407E-A947-70E740481C1C}">
+                <a14:useLocalDpi xmlns:a14="http://schemas.microsoft.com/office/drawing/2010/main" val="0"/>
+              </a:ext>
+            </a:extLst>
+          </a:blip>
+          <a:stretch>
+            <a:fillRect/>
+          </a:stretch>
+        </p:blipFill>
+        <p:spPr>
+          <a:xfrm>
+            <a:off x="6491605" y="4588510"/>
+            <a:ext cx="1664970" cy="554990"/>
+          </a:xfrm>
+          <a:prstGeom prst="rect">
+            <a:avLst/>
+          </a:prstGeom>
+        </p:spPr>
+      </p:pic>
+      <p:pic>
+        <p:nvPicPr>
+          <p:cNvPr id="7" name="Content Placeholder 6">
+            <a:extLst>
+              <a:ext uri="{FF2B5EF4-FFF2-40B4-BE49-F238E27FC236}">
+                <a16:creationId xmlns:a16="http://schemas.microsoft.com/office/drawing/2014/main" id="{74A4DC81-497E-D19A-3425-96F23C2B7974}"/>
+              </a:ext>
+            </a:extLst>
+          </p:cNvPr>
+          <p:cNvPicPr>
+            <a:picLocks noGrp="1" noChangeAspect="1"/>
+          </p:cNvPicPr>
+          <p:nvPr>
+            <p:ph idx="1"/>
+          </p:nvPr>
+        </p:nvPicPr>
+        <p:blipFill>
+          <a:blip r:embed="rId3" cstate="print">
+            <a:extLst>
+              <a:ext uri="{28A0092B-C50C-407E-A947-70E740481C1C}">
+                <a14:useLocalDpi xmlns:a14="http://schemas.microsoft.com/office/drawing/2010/main" val="0"/>
+              </a:ext>
+            </a:extLst>
+          </a:blip>
+          <a:stretch>
+            <a:fillRect/>
+          </a:stretch>
+        </p:blipFill>
+        <p:spPr>
+          <a:xfrm>
+            <a:off x="4572000" y="4606236"/>
+            <a:ext cx="1990725" cy="519537"/>
+          </a:xfrm>
+          <a:prstGeom prst="rect">
+            <a:avLst/>
+          </a:prstGeom>
+        </p:spPr>
+      </p:pic>
+      <p:sp>
+        <p:nvSpPr>
+          <p:cNvPr id="3" name="Tijdelijke aanduiding voor inhoud 2">
+            <a:extLst>
+              <a:ext uri="{FF2B5EF4-FFF2-40B4-BE49-F238E27FC236}">
+                <a16:creationId xmlns:a16="http://schemas.microsoft.com/office/drawing/2014/main" id="{B427C76F-C358-0FB5-953F-04290E619B06}"/>
+              </a:ext>
+            </a:extLst>
+          </p:cNvPr>
+          <p:cNvSpPr txBox="1">
+            <a:spLocks/>
+          </p:cNvSpPr>
+          <p:nvPr/>
+        </p:nvSpPr>
+        <p:spPr>
+          <a:xfrm>
+            <a:off x="758824" y="1306642"/>
+            <a:ext cx="7556501" cy="2922458"/>
+          </a:xfrm>
+          <a:prstGeom prst="rect">
+            <a:avLst/>
+          </a:prstGeom>
+        </p:spPr>
+        <p:txBody>
+          <a:bodyPr vert="horz" lIns="0" tIns="0" rIns="0" bIns="0" rtlCol="0">
+            <a:noAutofit/>
+          </a:bodyPr>
+          <a:lstStyle>
+            <a:lvl1pPr marL="0" indent="0" algn="l" defTabSz="685800" rtl="0" eaLnBrk="1" latinLnBrk="0" hangingPunct="1">
+              <a:lnSpc>
+                <a:spcPct val="100000"/>
+              </a:lnSpc>
+              <a:spcBef>
+                <a:spcPts val="0"/>
+              </a:spcBef>
+              <a:buFont typeface="Arial" panose="020B0604020202020204" pitchFamily="34" charset="0"/>
+              <a:buNone/>
+              <a:defRPr sz="1950" kern="1200" baseline="0">
+                <a:solidFill>
+                  <a:schemeClr val="tx1"/>
+                </a:solidFill>
+                <a:latin typeface="+mn-lt"/>
+                <a:ea typeface="+mn-ea"/>
+                <a:cs typeface="+mn-cs"/>
+              </a:defRPr>
+            </a:lvl1pPr>
+            <a:lvl2pPr marL="0" indent="0" algn="l" defTabSz="685800" rtl="0" eaLnBrk="1" latinLnBrk="0" hangingPunct="1">
+              <a:lnSpc>
+                <a:spcPct val="100000"/>
+              </a:lnSpc>
+              <a:spcBef>
+                <a:spcPts val="0"/>
+              </a:spcBef>
+              <a:buFont typeface="Arial" panose="020B0604020202020204" pitchFamily="34" charset="0"/>
+              <a:buNone/>
+              <a:defRPr sz="1650" kern="1200">
+                <a:solidFill>
+                  <a:schemeClr val="tx1"/>
+                </a:solidFill>
+                <a:latin typeface="+mn-lt"/>
+                <a:ea typeface="+mn-ea"/>
+                <a:cs typeface="+mn-cs"/>
+              </a:defRPr>
+            </a:lvl2pPr>
+            <a:lvl3pPr marL="180975" indent="-180975" algn="l" defTabSz="685800" rtl="0" eaLnBrk="1" latinLnBrk="0" hangingPunct="1">
+              <a:lnSpc>
+                <a:spcPct val="100000"/>
+              </a:lnSpc>
+              <a:spcBef>
+                <a:spcPts val="0"/>
+              </a:spcBef>
+              <a:buFont typeface="Arial" panose="020B0604020202020204" pitchFamily="34" charset="0"/>
+              <a:buChar char="•"/>
+              <a:defRPr sz="1650" kern="1200">
+                <a:solidFill>
+                  <a:schemeClr val="tx1"/>
+                </a:solidFill>
+                <a:latin typeface="+mn-lt"/>
+                <a:ea typeface="+mn-ea"/>
+                <a:cs typeface="+mn-cs"/>
+              </a:defRPr>
+            </a:lvl3pPr>
+            <a:lvl4pPr marL="360000" indent="-180975" algn="l" defTabSz="685800" rtl="0" eaLnBrk="1" latinLnBrk="0" hangingPunct="1">
+              <a:lnSpc>
+                <a:spcPct val="100000"/>
+              </a:lnSpc>
+              <a:spcBef>
+                <a:spcPts val="0"/>
+              </a:spcBef>
+              <a:buFont typeface="Arial" panose="020B0604020202020204" pitchFamily="34" charset="0"/>
+              <a:buChar char="•"/>
+              <a:defRPr sz="1650" kern="1200">
+                <a:solidFill>
+                  <a:schemeClr val="tx1"/>
+                </a:solidFill>
+                <a:latin typeface="+mn-lt"/>
+                <a:ea typeface="+mn-ea"/>
+                <a:cs typeface="+mn-cs"/>
+              </a:defRPr>
+            </a:lvl4pPr>
+            <a:lvl5pPr marL="539750" indent="-177800" algn="l" defTabSz="685800" rtl="0" eaLnBrk="1" latinLnBrk="0" hangingPunct="1">
+              <a:lnSpc>
+                <a:spcPct val="100000"/>
+              </a:lnSpc>
+              <a:spcBef>
+                <a:spcPts val="0"/>
+              </a:spcBef>
+              <a:buFont typeface="Arial" panose="020B0604020202020204" pitchFamily="34" charset="0"/>
+              <a:buChar char="•"/>
+              <a:defRPr sz="1650" kern="1200">
+                <a:solidFill>
+                  <a:schemeClr val="tx1"/>
+                </a:solidFill>
+                <a:latin typeface="+mn-lt"/>
+                <a:ea typeface="+mn-ea"/>
+                <a:cs typeface="+mn-cs"/>
+              </a:defRPr>
+            </a:lvl5pPr>
+            <a:lvl6pPr marL="1885950" indent="-171450" algn="l" defTabSz="685800" rtl="0" eaLnBrk="1" latinLnBrk="0" hangingPunct="1">
+              <a:lnSpc>
+                <a:spcPct val="90000"/>
+              </a:lnSpc>
+              <a:spcBef>
+                <a:spcPts val="375"/>
+              </a:spcBef>
+              <a:buFont typeface="Arial" panose="020B0604020202020204" pitchFamily="34" charset="0"/>
+              <a:buChar char="•"/>
+              <a:defRPr sz="1350" kern="1200">
+                <a:solidFill>
+                  <a:schemeClr val="tx1"/>
+                </a:solidFill>
+                <a:latin typeface="+mn-lt"/>
+                <a:ea typeface="+mn-ea"/>
+                <a:cs typeface="+mn-cs"/>
+              </a:defRPr>
+            </a:lvl6pPr>
+            <a:lvl7pPr marL="2228850" indent="-171450" algn="l" defTabSz="685800" rtl="0" eaLnBrk="1" latinLnBrk="0" hangingPunct="1">
+              <a:lnSpc>
+                <a:spcPct val="90000"/>
+              </a:lnSpc>
+              <a:spcBef>
+                <a:spcPts val="375"/>
+              </a:spcBef>
+              <a:buFont typeface="Arial" panose="020B0604020202020204" pitchFamily="34" charset="0"/>
+              <a:buChar char="•"/>
+              <a:defRPr sz="1350" kern="1200">
+                <a:solidFill>
+                  <a:schemeClr val="tx1"/>
+                </a:solidFill>
+                <a:latin typeface="+mn-lt"/>
+                <a:ea typeface="+mn-ea"/>
+                <a:cs typeface="+mn-cs"/>
+              </a:defRPr>
+            </a:lvl7pPr>
+            <a:lvl8pPr marL="2571750" indent="-171450" algn="l" defTabSz="685800" rtl="0" eaLnBrk="1" latinLnBrk="0" hangingPunct="1">
+              <a:lnSpc>
+                <a:spcPct val="90000"/>
+              </a:lnSpc>
+              <a:spcBef>
+                <a:spcPts val="375"/>
+              </a:spcBef>
+              <a:buFont typeface="Arial" panose="020B0604020202020204" pitchFamily="34" charset="0"/>
+              <a:buChar char="•"/>
+              <a:defRPr sz="1350" kern="1200">
+                <a:solidFill>
+                  <a:schemeClr val="tx1"/>
+                </a:solidFill>
+                <a:latin typeface="+mn-lt"/>
+                <a:ea typeface="+mn-ea"/>
+                <a:cs typeface="+mn-cs"/>
+              </a:defRPr>
+            </a:lvl8pPr>
+            <a:lvl9pPr marL="2914650" indent="-171450" algn="l" defTabSz="685800" rtl="0" eaLnBrk="1" latinLnBrk="0" hangingPunct="1">
+              <a:lnSpc>
+                <a:spcPct val="90000"/>
+              </a:lnSpc>
+              <a:spcBef>
+                <a:spcPts val="375"/>
+              </a:spcBef>
+              <a:buFont typeface="Arial" panose="020B0604020202020204" pitchFamily="34" charset="0"/>
+              <a:buChar char="•"/>
+              <a:defRPr sz="1350" kern="1200">
+                <a:solidFill>
+                  <a:schemeClr val="tx1"/>
+                </a:solidFill>
+                <a:latin typeface="+mn-lt"/>
+                <a:ea typeface="+mn-ea"/>
+                <a:cs typeface="+mn-cs"/>
+              </a:defRPr>
+            </a:lvl9pPr>
+          </a:lstStyle>
+          <a:p>
+            <a:r>
+              <a:rPr lang="en-US"/>
+              <a:t>The </a:t>
+            </a:r>
+            <a:r>
+              <a:rPr lang="en-US" dirty="0"/>
+              <a:t>highest-value next work is calibration before broad tumor </a:t>
+            </a:r>
+            <a:r>
+              <a:rPr lang="en-US"/>
+              <a:t>sweeps.</a:t>
+            </a:r>
+            <a:br>
+              <a:rPr lang="en-US" dirty="0"/>
+            </a:br>
+            <a:endParaRPr lang="en-GB" dirty="0"/>
+          </a:p>
+          <a:p>
+            <a:pPr lvl="2"/>
+            <a:r>
+              <a:rPr lang="en-GB" dirty="0"/>
+              <a:t>Run and evaluate soft-interior volumetric-skin scout.</a:t>
+            </a:r>
+          </a:p>
+          <a:p>
+            <a:pPr lvl="2"/>
+            <a:r>
+              <a:rPr lang="en-GB" dirty="0"/>
+              <a:t>Select primary dynamic excitation amplitude.</a:t>
+            </a:r>
+          </a:p>
+          <a:p>
+            <a:pPr lvl="2"/>
+            <a:r>
+              <a:rPr lang="en-GB" dirty="0"/>
+              <a:t>Run matched no-</a:t>
+            </a:r>
+            <a:r>
+              <a:rPr lang="en-GB" dirty="0" err="1"/>
+              <a:t>tumor</a:t>
+            </a:r>
+            <a:r>
+              <a:rPr lang="en-GB" dirty="0"/>
+              <a:t> versus upper-outer </a:t>
+            </a:r>
+            <a:r>
+              <a:rPr lang="en-GB" dirty="0" err="1"/>
+              <a:t>tumor</a:t>
+            </a:r>
+            <a:r>
+              <a:rPr lang="en-GB" dirty="0"/>
+              <a:t> cases.</a:t>
+            </a:r>
+          </a:p>
+          <a:p>
+            <a:pPr lvl="2"/>
+            <a:r>
+              <a:rPr lang="en-GB" dirty="0"/>
+              <a:t>Improve surface/landmark postprocess reliability.</a:t>
+            </a:r>
+          </a:p>
+          <a:p>
+            <a:pPr lvl="2"/>
+            <a:r>
+              <a:rPr lang="en-GB" dirty="0"/>
+              <a:t>Extend later toward patient-specific anatomy and real EWS measurements.</a:t>
+            </a:r>
+          </a:p>
+          <a:p>
+            <a:pPr lvl="2"/>
+            <a:endParaRPr lang="en-GB" dirty="0"/>
+          </a:p>
+        </p:txBody>
+      </p:sp>
+    </p:spTree>
+    <p:extLst>
+      <p:ext uri="{BB962C8B-B14F-4D97-AF65-F5344CB8AC3E}">
+        <p14:creationId xmlns:p14="http://schemas.microsoft.com/office/powerpoint/2010/main" val="159822574"/>
+      </p:ext>
+    </p:extLst>
+  </p:cSld>
+  <p:clrMapOvr>
+    <a:masterClrMapping/>
+  </p:clrMapOvr>
+  <mc:AlternateContent xmlns:mc="http://schemas.openxmlformats.org/markup-compatibility/2006" xmlns:p14="http://schemas.microsoft.com/office/powerpoint/2010/main">
+    <mc:Choice Requires="p14">
+      <p:transition spd="med" p14:dur="700">
+        <p:fade/>
+      </p:transition>
+    </mc:Choice>
+    <mc:Fallback xmlns="">
+      <p:transition spd="med">
+        <p:fade/>
+      </p:transition>
+    </mc:Fallback>
+  </mc:AlternateContent>
+</p:sld>
+</file>
+
+<file path=ppt/slides/slide21.xml><?xml version="1.0" encoding="utf-8"?>
+<p:sld xmlns:a="http://schemas.openxmlformats.org/drawingml/2006/main" xmlns:r="http://schemas.openxmlformats.org/officeDocument/2006/relationships" xmlns:p="http://schemas.openxmlformats.org/presentationml/2006/main">
+  <p:cSld>
     <p:bg>
       <p:bgPr>
         <a:blipFill dpi="0" rotWithShape="1">
@@ -11244,13 +12013,13 @@
   <p:clrMapOvr>
     <a:masterClrMapping/>
   </p:clrMapOvr>
-  <mc:AlternateContent xmlns:mc="http://schemas.openxmlformats.org/markup-compatibility/2006">
-    <mc:Choice xmlns:p14="http://schemas.microsoft.com/office/powerpoint/2010/main" Requires="p14">
+  <mc:AlternateContent xmlns:mc="http://schemas.openxmlformats.org/markup-compatibility/2006" xmlns:p14="http://schemas.microsoft.com/office/powerpoint/2010/main">
+    <mc:Choice Requires="p14">
       <p:transition spd="med" p14:dur="700">
         <p:fade/>
       </p:transition>
     </mc:Choice>
-    <mc:Fallback>
+    <mc:Fallback xmlns="">
       <p:transition spd="med">
         <p:fade/>
       </p:transition>

</xml_diff>